<commit_message>
Degree-share labels on flow destinations; destinations slide as ideas
The employed-flow charts now label other professional (2 in 3 workers
hold a degree, 67% computed from ASEC 2021-25) and sales, office and
manual (1 in 5, 21%). The where-leavers-go slide is three message
bullets instead of a list.

Co-Authored-By: Claude Fable 5 <noreply@anthropic.com>
Claude-Session: https://claude.ai/code/session_01DNzQPDcr3zfLTraMHUHqUn
</commit_message>
<xml_diff>
--- a/report/data_cluster/whereleaversgo_slide.pptx
+++ b/report/data_cluster/whereleaversgo_slide.pptx
@@ -3112,14 +3112,14 @@
           <a:p>
             <a:pPr>
               <a:lnSpc>
-                <a:spcPts val="3528"/>
+                <a:spcPts val="3584"/>
               </a:lnSpc>
               <a:spcAft>
                 <a:spcPts val="0"/>
               </a:spcAft>
             </a:pPr>
             <a:r>
-              <a:rPr sz="2800" b="1" i="0">
+              <a:rPr sz="2800" b="1">
                 <a:solidFill>
                   <a:srgbClr val="102D5E"/>
                 </a:solidFill>
@@ -3138,7 +3138,7 @@
         </p:nvSpPr>
         <p:spPr>
           <a:xfrm>
-            <a:off x="822960" y="1417320"/>
+            <a:off x="822960" y="1554480"/>
             <a:ext cx="10789920" cy="914400"/>
           </a:xfrm>
           <a:prstGeom prst="rect">
@@ -3154,14 +3154,14 @@
           <a:p>
             <a:pPr>
               <a:lnSpc>
-                <a:spcPts val="2394"/>
+                <a:spcPts val="2560"/>
               </a:lnSpc>
               <a:spcAft>
-                <a:spcPts val="2000"/>
+                <a:spcPts val="2400"/>
               </a:spcAft>
             </a:pPr>
             <a:r>
-              <a:rPr sz="1900" b="1" i="0">
+              <a:rPr sz="2000" b="1">
                 <a:solidFill>
                   <a:srgbClr val="2D6CB5"/>
                 </a:solidFill>
@@ -3170,35 +3170,35 @@
               <a:t>▪  </a:t>
             </a:r>
             <a:r>
-              <a:rPr sz="1900" b="1" i="0">
+              <a:rPr sz="2000" b="1">
                 <a:solidFill>
                   <a:srgbClr val="102D5E"/>
                 </a:solidFill>
                 <a:latin typeface="Garamond"/>
               </a:rPr>
-              <a:t>Education, non-teaching — 23%.  </a:t>
-            </a:r>
-            <a:r>
-              <a:rPr sz="1900" b="0" i="0">
+              <a:t>Leaving the classroom rarely means leaving education.  </a:t>
+            </a:r>
+            <a:r>
+              <a:rPr sz="2000" b="0">
                 <a:solidFill>
                   <a:srgbClr val="212529"/>
                 </a:solidFill>
                 <a:latin typeface="Garamond"/>
               </a:rPr>
-              <a:t>Postsecondary teachers (8%), tutors (4%), teaching assistants (4%), education administrators (3%), librarians (2%).</a:t>
+              <a:t>One in three employed leavers stays in education or care: lecturers, tutors, administrators, counselors.</a:t>
             </a:r>
           </a:p>
           <a:p>
             <a:pPr>
               <a:lnSpc>
-                <a:spcPts val="2394"/>
+                <a:spcPts val="2560"/>
               </a:lnSpc>
               <a:spcAft>
-                <a:spcPts val="2000"/>
+                <a:spcPts val="2400"/>
               </a:spcAft>
             </a:pPr>
             <a:r>
-              <a:rPr sz="1900" b="1" i="0">
+              <a:rPr sz="2000" b="1">
                 <a:solidFill>
                   <a:srgbClr val="2D6CB5"/>
                 </a:solidFill>
@@ -3207,35 +3207,35 @@
               <a:t>▪  </a:t>
             </a:r>
             <a:r>
-              <a:rPr sz="1900" b="1" i="0">
+              <a:rPr sz="2000" b="1">
                 <a:solidFill>
                   <a:srgbClr val="102D5E"/>
                 </a:solidFill>
                 <a:latin typeface="Garamond"/>
               </a:rPr>
-              <a:t>Care — 9%.  </a:t>
-            </a:r>
-            <a:r>
-              <a:rPr sz="1900" b="0" i="0">
+              <a:t>The clearest step up is the exception, not the rule.  </a:t>
+            </a:r>
+            <a:r>
+              <a:rPr sz="2000" b="0">
                 <a:solidFill>
                   <a:srgbClr val="212529"/>
                 </a:solidFill>
                 <a:latin typeface="Garamond"/>
               </a:rPr>
-              <a:t>Educational and career counselors (2%), social and human service assistants (1%), social workers (1%), childcare workers (1%).</a:t>
+              <a:t>The single biggest destination is management (10%), and professional jobs take another fifth — but no other destination reaches 3%.</a:t>
             </a:r>
           </a:p>
           <a:p>
             <a:pPr>
               <a:lnSpc>
-                <a:spcPts val="2394"/>
+                <a:spcPts val="2560"/>
               </a:lnSpc>
               <a:spcAft>
-                <a:spcPts val="2000"/>
+                <a:spcPts val="2400"/>
               </a:spcAft>
             </a:pPr>
             <a:r>
-              <a:rPr sz="1900" b="1" i="0">
+              <a:rPr sz="2000" b="1">
                 <a:solidFill>
                   <a:srgbClr val="2D6CB5"/>
                 </a:solidFill>
@@ -3244,59 +3244,22 @@
               <a:t>▪  </a:t>
             </a:r>
             <a:r>
-              <a:rPr sz="1900" b="1" i="0">
+              <a:rPr sz="2000" b="1">
                 <a:solidFill>
                   <a:srgbClr val="102D5E"/>
                 </a:solidFill>
                 <a:latin typeface="Garamond"/>
               </a:rPr>
-              <a:t>Other professional and managerial — 32%.  </a:t>
-            </a:r>
-            <a:r>
-              <a:rPr sz="1900" b="0" i="0">
+              <a:t>For more than a third, leaving means stepping off the degree track.  </a:t>
+            </a:r>
+            <a:r>
+              <a:rPr sz="2000" b="0">
                 <a:solidFill>
                   <a:srgbClr val="212529"/>
                 </a:solidFill>
                 <a:latin typeface="Garamond"/>
               </a:rPr>
-              <a:t>Managers (10%), coaches (2%), architects (2%), business operations specialists (1%).</a:t>
-            </a:r>
-          </a:p>
-          <a:p>
-            <a:pPr>
-              <a:lnSpc>
-                <a:spcPts val="2394"/>
-              </a:lnSpc>
-              <a:spcAft>
-                <a:spcPts val="2000"/>
-              </a:spcAft>
-            </a:pPr>
-            <a:r>
-              <a:rPr sz="1900" b="1" i="0">
-                <a:solidFill>
-                  <a:srgbClr val="2D6CB5"/>
-                </a:solidFill>
-                <a:latin typeface="Garamond"/>
-              </a:rPr>
-              <a:t>▪  </a:t>
-            </a:r>
-            <a:r>
-              <a:rPr sz="1900" b="1" i="0">
-                <a:solidFill>
-                  <a:srgbClr val="102D5E"/>
-                </a:solidFill>
-                <a:latin typeface="Garamond"/>
-              </a:rPr>
-              <a:t>Sales, office and manual — 36%.  </a:t>
-            </a:r>
-            <a:r>
-              <a:rPr sz="1900" b="0" i="0">
-                <a:solidFill>
-                  <a:srgbClr val="212529"/>
-                </a:solidFill>
-                <a:latin typeface="Garamond"/>
-              </a:rPr>
-              <a:t>Secretaries (3%), retail salespersons (2%), landscaping (2%), exercise trainers (2%), taxi drivers (1%) — almost entirely occupations where most workers hold no college degree.</a:t>
+              <a:t>36% land in sales, office and manual work, where only one in five workers holds a college degree.</a:t>
             </a:r>
           </a:p>
         </p:txBody>
@@ -3325,14 +3288,14 @@
           <a:p>
             <a:pPr>
               <a:lnSpc>
-                <a:spcPts val="2016"/>
+                <a:spcPts val="2048"/>
               </a:lnSpc>
               <a:spcAft>
                 <a:spcPts val="0"/>
               </a:spcAft>
             </a:pPr>
             <a:r>
-              <a:rPr sz="1600" b="1" i="0">
+              <a:rPr sz="1600" b="1">
                 <a:solidFill>
                   <a:srgbClr val="102D5E"/>
                 </a:solidFill>
@@ -3341,13 +3304,13 @@
               <a:t>Key message.  </a:t>
             </a:r>
             <a:r>
-              <a:rPr sz="1600" b="0" i="0">
+              <a:rPr sz="1600" b="0">
                 <a:solidFill>
                   <a:srgbClr val="212529"/>
                 </a:solidFill>
                 <a:latin typeface="Garamond"/>
               </a:rPr>
-              <a:t>More than a third of the employed leavers move to occupations where most workers hold no college degree. Leaving teaching usually means leaving the profession, not moving up.</a:t>
+              <a:t>Leaving teaching usually means leaving the profession, not moving up.</a:t>
             </a:r>
           </a:p>
         </p:txBody>

</xml_diff>

<commit_message>
Fix inverted message on destinations slide: most leave education for good
Co-Authored-By: Claude Fable 5 <noreply@anthropic.com>
Claude-Session: https://claude.ai/code/session_01DNzQPDcr3zfLTraMHUHqUn
</commit_message>
<xml_diff>
--- a/report/data_cluster/whereleaversgo_slide.pptx
+++ b/report/data_cluster/whereleaversgo_slide.pptx
@@ -3176,7 +3176,7 @@
                 </a:solidFill>
                 <a:latin typeface="Garamond"/>
               </a:rPr>
-              <a:t>Leaving the classroom rarely means leaving education.  </a:t>
+              <a:t>Most leave education for good.  </a:t>
             </a:r>
             <a:r>
               <a:rPr sz="2000" b="0">
@@ -3185,7 +3185,7 @@
                 </a:solidFill>
                 <a:latin typeface="Garamond"/>
               </a:rPr>
-              <a:t>One in three employed leavers stays in education or care: lecturers, tutors, administrators, counselors.</a:t>
+              <a:t>Only one in three employed leavers stays in an education or care job (lecturers, tutors, administrators, counselors); the other two thirds leave the sector entirely.</a:t>
             </a:r>
           </a:p>
           <a:p>
@@ -3222,7 +3222,7 @@
                 </a:solidFill>
                 <a:latin typeface="Garamond"/>
               </a:rPr>
-              <a:t>The single biggest destination is management (10%), and professional jobs take another fifth — but no other destination reaches 3%.</a:t>
+              <a:t>Management is the single biggest destination (10%); no other destination reaches 3%.</a:t>
             </a:r>
           </a:p>
           <a:p>

</xml_diff>